<commit_message>
Refactor presenter scripts for clarity and timing adjustments
- Updated the 30-minute presenter script for "Outsmart Your Lying, Cheating Students" to clarify slide timings and content, including adjustments to the delivery notes and bridge statements.
- Revised the 15-minute and 30-minute scripts for "Buy Me a Free Tier" to enhance clarity, remove unnecessary slides, and adjust timings for better flow.
- Made changes to the 15-minute and 30-minute scripts for "The Future of Product Engineering," including timing adjustments and content refinement to improve the presentation structure.
- Corrected minor issues in the audit benchmarks documentation to ensure accurate citations and clarity in the source references.
</commit_message>
<xml_diff>
--- a/artifacts/speaking-portfolio-expanded/decks/adaptive-systems-15min-screen.pptx
+++ b/artifacts/speaking-portfolio-expanded/decks/adaptive-systems-15min-screen.pptx
@@ -15,7 +15,6 @@
     <p:sldId id="260" r:id="rIdSlide5"/>
     <p:sldId id="261" r:id="rIdSlide6"/>
     <p:sldId id="262" r:id="rIdSlide7"/>
-    <p:sldId id="263" r:id="rIdSlide8"/>
   </p:sldIdLst>
   <p:sldSz cx="13716000" cy="8572500" type="custom"/>
   <p:notesSz cx="6858000" cy="9144000"/>
@@ -146,7 +145,7 @@
                 <a:ea typeface="Arial"/>
                 <a:cs typeface="Arial"/>
               </a:rPr>
-              <a:t xml:space="preserve">Source slide 1. 00:00 to 01:00</a:t>
+              <a:t xml:space="preserve">Source slide 1. 00:00 to 01:45</a:t>
             </a:r>
             <a:endParaRPr lang="en-US" sz="1200"/>
           </a:p>
@@ -673,7 +672,7 @@
                 <a:ea typeface="Arial"/>
                 <a:cs typeface="Arial"/>
               </a:rPr>
-              <a:t xml:space="preserve">Source slide 3. 01:00 to 02:30</a:t>
+              <a:t xml:space="preserve">Source slide 3. 01:45 to 05:15</a:t>
             </a:r>
             <a:endParaRPr lang="en-US" sz="1200"/>
           </a:p>
@@ -857,7 +856,7 @@
                 <a:ea typeface="Arial"/>
                 <a:cs typeface="Arial"/>
               </a:rPr>
-              <a:t xml:space="preserve">Zoom out from the ingest job. The assistant with every customer's data and a toolbox that can send email, issue refunds, delete records and ship code is not a design we get to decline. It is arriving one integration at a time, and not only in our products. Browsers now ship a chat that drives the page. WebMCP lets an agent act on any site that opts in, and the list of sites that opt in only goes one direction. The next generation of CLIs will take natural language by default, and you will pass `--no-agent` to get the old behavior back. The intermediary intelligence layer is going to wrap everything, and I know who to blame: the kids. Actually, the kids hate AI. It will be their kids who demand an agent safety blanket on everything. I will be in a rocking chair explaining that the internet was better on vinyl.</a:t>
+              <a:t xml:space="preserve">Zoom out from the ingest job. The assistant with every customer's data and a toolbox that can send email, issue refunds, delete records and ship code is not a design we get to decline. It is arriving one integration at a time, and not only in our products.</a:t>
             </a:r>
             <a:endParaRPr lang="en-US" sz="1200"/>
           </a:p>
@@ -1087,7 +1086,7 @@
                 <a:ea typeface="Arial"/>
                 <a:cs typeface="Arial"/>
               </a:rPr>
-              <a:t xml:space="preserve"/>
+              <a:t xml:space="preserve">Bridge: most of the damage will be accidents before anyone means it, and a renamed field is untrusted input read by something that can act.</a:t>
             </a:r>
             <a:endParaRPr lang="en-US" sz="1200"/>
           </a:p>
@@ -1200,7 +1199,7 @@
                 <a:ea typeface="Arial"/>
                 <a:cs typeface="Arial"/>
               </a:rPr>
-              <a:t xml:space="preserve">Source slide 4. 02:30 to 05:30</a:t>
+              <a:t xml:space="preserve">Source slide 4. 05:15 to 07:00</a:t>
             </a:r>
             <a:endParaRPr lang="en-US" sz="1200"/>
           </a:p>
@@ -1431,52 +1430,6 @@
                 <a:cs typeface="Arial"/>
               </a:rPr>
               <a:t xml:space="preserve">If the agent needs something else, it asks. Dynamic tool search lets it discover a tool; policy decides whether this job may have it; the request and the answer are logged whether or not it was granted. That log is the most interesting file in the system.</a:t>
-            </a:r>
-            <a:endParaRPr lang="en-US" sz="1200"/>
-          </a:p>
-          <a:p>
-            <a:pPr marL="0" indent="0">
-              <a:lnSpc>
-                <a:spcPts val="1560"/>
-              </a:lnSpc>
-              <a:spcAft>
-                <a:spcPts val="0"/>
-              </a:spcAft>
-              <a:buNone/>
-            </a:pPr>
-            <a:r>
-              <a:rPr lang="en-US" sz="1200" b="0">
-                <a:solidFill>
-                  <a:srgbClr val="202b33"/>
-                </a:solidFill>
-                <a:latin typeface="Arial"/>
-                <a:ea typeface="Arial"/>
-                <a:cs typeface="Arial"/>
-              </a:rPr>
-              <a:t xml:space="preserve"/>
-            </a:r>
-            <a:endParaRPr lang="en-US" sz="1200"/>
-          </a:p>
-          <a:p>
-            <a:pPr marL="0" indent="0">
-              <a:lnSpc>
-                <a:spcPts val="1560"/>
-              </a:lnSpc>
-              <a:spcAft>
-                <a:spcPts val="0"/>
-              </a:spcAft>
-              <a:buNone/>
-            </a:pPr>
-            <a:r>
-              <a:rPr lang="en-US" sz="1200" b="0">
-                <a:solidFill>
-                  <a:srgbClr val="202b33"/>
-                </a:solidFill>
-                <a:latin typeface="Arial"/>
-                <a:ea typeface="Arial"/>
-                <a:cs typeface="Arial"/>
-              </a:rPr>
-              <a:t xml:space="preserve">I have this working as a prototype on my own integrations. I am not going to give you a success rate today, because I do not have one I trust yet. I can tell you the log of denied tool requests taught me more about my own permissions than any audit.</a:t>
             </a:r>
             <a:endParaRPr lang="en-US" sz="1200"/>
           </a:p>
@@ -1727,7 +1680,7 @@
                 <a:ea typeface="Arial"/>
                 <a:cs typeface="Arial"/>
               </a:rPr>
-              <a:t xml:space="preserve">Source slide 5. 05:30 to 07:00</a:t>
+              <a:t xml:space="preserve">Source slide 5. 07:00 to 08:30</a:t>
             </a:r>
             <a:endParaRPr lang="en-US" sz="1200"/>
           </a:p>
@@ -1957,52 +1910,6 @@
                 <a:ea typeface="Arial"/>
                 <a:cs typeface="Arial"/>
               </a:rPr>
-              <a:t xml:space="preserve">This is least privilege, and Saltzer and Schroeder wrote it down in 1975: every program runs with the least set of privileges the job needs. We have all been nodding at that for fifty years and shipping service accounts that can do anything. A per-job agent is the first thing I have built where complying is genuinely easier than not.</a:t>
-            </a:r>
-            <a:endParaRPr lang="en-US" sz="1200"/>
-          </a:p>
-          <a:p>
-            <a:pPr marL="0" indent="0">
-              <a:lnSpc>
-                <a:spcPts val="1560"/>
-              </a:lnSpc>
-              <a:spcAft>
-                <a:spcPts val="0"/>
-              </a:spcAft>
-              <a:buNone/>
-            </a:pPr>
-            <a:r>
-              <a:rPr lang="en-US" sz="1200" b="0">
-                <a:solidFill>
-                  <a:srgbClr val="202b33"/>
-                </a:solidFill>
-                <a:latin typeface="Arial"/>
-                <a:ea typeface="Arial"/>
-                <a:cs typeface="Arial"/>
-              </a:rPr>
-              <a:t xml:space="preserve"/>
-            </a:r>
-            <a:endParaRPr lang="en-US" sz="1200"/>
-          </a:p>
-          <a:p>
-            <a:pPr marL="0" indent="0">
-              <a:lnSpc>
-                <a:spcPts val="1560"/>
-              </a:lnSpc>
-              <a:spcAft>
-                <a:spcPts val="0"/>
-              </a:spcAft>
-              <a:buNone/>
-            </a:pPr>
-            <a:r>
-              <a:rPr lang="en-US" sz="1200" b="0">
-                <a:solidFill>
-                  <a:srgbClr val="202b33"/>
-                </a:solidFill>
-                <a:latin typeface="Arial"/>
-                <a:ea typeface="Arial"/>
-                <a:cs typeface="Arial"/>
-              </a:rPr>
               <a:t xml:space="preserve">Second, watch the boundary between systems. An agent that can read customer data and an agent that can post to a vendor are two agents, with a filter between them. That is where data leaks: not through the model being evil, but through a tool result flowing into the next tool call.</a:t>
             </a:r>
             <a:endParaRPr lang="en-US" sz="1200"/>
@@ -2049,52 +1956,6 @@
                 <a:ea typeface="Arial"/>
                 <a:cs typeface="Arial"/>
               </a:rPr>
-              <a:t xml:space="preserve">For sensitive processing, the planner gets an opaque job reference. A trusted dispatcher grants a local worker scoped access; the worker touches the data; only an allowlisted status comes back. A signed download URL is a bearer credential. Handing it to a model while asking the model not to use it is not isolation, it is hope.</a:t>
-            </a:r>
-            <a:endParaRPr lang="en-US" sz="1200"/>
-          </a:p>
-          <a:p>
-            <a:pPr marL="0" indent="0">
-              <a:lnSpc>
-                <a:spcPts val="1560"/>
-              </a:lnSpc>
-              <a:spcAft>
-                <a:spcPts val="0"/>
-              </a:spcAft>
-              <a:buNone/>
-            </a:pPr>
-            <a:r>
-              <a:rPr lang="en-US" sz="1200" b="0">
-                <a:solidFill>
-                  <a:srgbClr val="202b33"/>
-                </a:solidFill>
-                <a:latin typeface="Arial"/>
-                <a:ea typeface="Arial"/>
-                <a:cs typeface="Arial"/>
-              </a:rPr>
-              <a:t xml:space="preserve"/>
-            </a:r>
-            <a:endParaRPr lang="en-US" sz="1200"/>
-          </a:p>
-          <a:p>
-            <a:pPr marL="0" indent="0">
-              <a:lnSpc>
-                <a:spcPts val="1560"/>
-              </a:lnSpc>
-              <a:spcAft>
-                <a:spcPts val="0"/>
-              </a:spcAft>
-              <a:buNone/>
-            </a:pPr>
-            <a:r>
-              <a:rPr lang="en-US" sz="1200" b="0">
-                <a:solidFill>
-                  <a:srgbClr val="202b33"/>
-                </a:solidFill>
-                <a:latin typeface="Arial"/>
-                <a:ea typeface="Arial"/>
-                <a:cs typeface="Arial"/>
-              </a:rPr>
               <a:t xml:space="preserve">Saltzer and Schroeder (1975), [The Protection of Information in Computer Systems](https://doi.org/10.1109/PROC.1975.9939), Proceedings of the IEEE 63(9), 1278 to 1308. Least privilege is their principle (f).</a:t>
             </a:r>
             <a:endParaRPr lang="en-US" sz="1200"/>
@@ -2233,7 +2094,7 @@
                 <a:ea typeface="Arial"/>
                 <a:cs typeface="Arial"/>
               </a:rPr>
-              <a:t xml:space="preserve"/>
+              <a:t xml:space="preserve">Bridge: this is least privilege, written down by Saltzer and Schroeder in 1975; a per-job agent is the first design where complying is easier than not.</a:t>
             </a:r>
             <a:endParaRPr lang="en-US" sz="1200"/>
           </a:p>
@@ -2346,7 +2207,7 @@
                 <a:ea typeface="Arial"/>
                 <a:cs typeface="Arial"/>
               </a:rPr>
-              <a:t xml:space="preserve">Source slide 6. 07:00 to 08:30</a:t>
+              <a:t xml:space="preserve">Source slide 6. 08:30 to 09:45</a:t>
             </a:r>
             <a:endParaRPr lang="en-US" sz="1200"/>
           </a:p>
@@ -2530,52 +2391,6 @@
                 <a:ea typeface="Arial"/>
                 <a:cs typeface="Arial"/>
               </a:rPr>
-              <a:t xml:space="preserve">A Boolean status becoming an enum is harder. Does true mean active, eligible, verified, or anything except cancelled? Pending cannot become true just because both are truthy in JavaScript.</a:t>
-            </a:r>
-            <a:endParaRPr lang="en-US" sz="1200"/>
-          </a:p>
-          <a:p>
-            <a:pPr marL="0" indent="0">
-              <a:lnSpc>
-                <a:spcPts val="1560"/>
-              </a:lnSpc>
-              <a:spcAft>
-                <a:spcPts val="0"/>
-              </a:spcAft>
-              <a:buNone/>
-            </a:pPr>
-            <a:r>
-              <a:rPr lang="en-US" sz="1200" b="0">
-                <a:solidFill>
-                  <a:srgbClr val="202b33"/>
-                </a:solidFill>
-                <a:latin typeface="Arial"/>
-                <a:ea typeface="Arial"/>
-                <a:cs typeface="Arial"/>
-              </a:rPr>
-              <a:t xml:space="preserve"/>
-            </a:r>
-            <a:endParaRPr lang="en-US" sz="1200"/>
-          </a:p>
-          <a:p>
-            <a:pPr marL="0" indent="0">
-              <a:lnSpc>
-                <a:spcPts val="1560"/>
-              </a:lnSpc>
-              <a:spcAft>
-                <a:spcPts val="0"/>
-              </a:spcAft>
-              <a:buNone/>
-            </a:pPr>
-            <a:r>
-              <a:rPr lang="en-US" sz="1200" b="0">
-                <a:solidFill>
-                  <a:srgbClr val="202b33"/>
-                </a:solidFill>
-                <a:latin typeface="Arial"/>
-                <a:ea typeface="Arial"/>
-                <a:cs typeface="Arial"/>
-              </a:rPr>
               <a:t xml:space="preserve">So the generated agent may propose a reversible mapping when evidence supports equivalence, and it must quarantine the rest. An unexplained business-state change goes to an owner with samples and a question. Automatic recovery is useful precisely because it has somewhere honest to stop.</a:t>
             </a:r>
             <a:endParaRPr lang="en-US" sz="1200"/>
@@ -2714,7 +2529,7 @@
                 <a:ea typeface="Arial"/>
                 <a:cs typeface="Arial"/>
               </a:rPr>
-              <a:t xml:space="preserve">Bridge: a repair ships as a versioned artifact with a rollback, and it has to pass fixtures it did not write.</a:t>
+              <a:t xml:space="preserve">Bridge: a Boolean status becoming an enum is the hard case — pending does not become true because both are truthy. A repair ships as a versioned artifact with a rollback, and it has to pass fixtures it did not write.</a:t>
             </a:r>
             <a:endParaRPr lang="en-US" sz="1200"/>
           </a:p>
@@ -2827,7 +2642,7 @@
                 <a:ea typeface="Arial"/>
                 <a:cs typeface="Arial"/>
               </a:rPr>
-              <a:t xml:space="preserve">Source slide 10. 08:30 to 11:30</a:t>
+              <a:t xml:space="preserve">Source slide 10. 09:45 to 12:45</a:t>
             </a:r>
             <a:endParaRPr lang="en-US" sz="1200"/>
           </a:p>
@@ -3400,626 +3215,7 @@
                 <a:ea typeface="Arial"/>
                 <a:cs typeface="Arial"/>
               </a:rPr>
-              <a:t xml:space="preserve">Source slide 14. 11:30 to 14:00</a:t>
-            </a:r>
-            <a:endParaRPr lang="en-US" sz="1200"/>
-          </a:p>
-          <a:p>
-            <a:pPr marL="0" indent="0">
-              <a:lnSpc>
-                <a:spcPts val="1560"/>
-              </a:lnSpc>
-              <a:spcAft>
-                <a:spcPts val="0"/>
-              </a:spcAft>
-              <a:buNone/>
-            </a:pPr>
-            <a:r>
-              <a:rPr lang="en-US" sz="1200" b="0">
-                <a:solidFill>
-                  <a:srgbClr val="202b33"/>
-                </a:solidFill>
-                <a:latin typeface="Arial"/>
-                <a:ea typeface="Arial"/>
-                <a:cs typeface="Arial"/>
-              </a:rPr>
-              <a:t xml:space="preserve"/>
-            </a:r>
-            <a:endParaRPr lang="en-US" sz="1200"/>
-          </a:p>
-          <a:p>
-            <a:pPr marL="0" indent="0">
-              <a:lnSpc>
-                <a:spcPts val="1560"/>
-              </a:lnSpc>
-              <a:spcAft>
-                <a:spcPts val="0"/>
-              </a:spcAft>
-              <a:buNone/>
-            </a:pPr>
-            <a:r>
-              <a:rPr lang="en-US" sz="1200" b="0">
-                <a:solidFill>
-                  <a:srgbClr val="202b33"/>
-                </a:solidFill>
-                <a:latin typeface="Arial"/>
-                <a:ea typeface="Arial"/>
-                <a:cs typeface="Arial"/>
-              </a:rPr>
-              <a:t xml:space="preserve">Before returning: check relevant memory and correct known mistakes</a:t>
-            </a:r>
-            <a:endParaRPr lang="en-US" sz="1200"/>
-          </a:p>
-          <a:p>
-            <a:pPr marL="0" indent="0">
-              <a:lnSpc>
-                <a:spcPts val="1560"/>
-              </a:lnSpc>
-              <a:spcAft>
-                <a:spcPts val="0"/>
-              </a:spcAft>
-              <a:buNone/>
-            </a:pPr>
-            <a:r>
-              <a:rPr lang="en-US" sz="1200" b="0">
-                <a:solidFill>
-                  <a:srgbClr val="202b33"/>
-                </a:solidFill>
-                <a:latin typeface="Arial"/>
-                <a:ea typeface="Arial"/>
-                <a:cs typeface="Arial"/>
-              </a:rPr>
-              <a:t xml:space="preserve"/>
-            </a:r>
-            <a:endParaRPr lang="en-US" sz="1200"/>
-          </a:p>
-          <a:p>
-            <a:pPr marL="0" indent="0">
-              <a:lnSpc>
-                <a:spcPts val="1560"/>
-              </a:lnSpc>
-              <a:spcAft>
-                <a:spcPts val="0"/>
-              </a:spcAft>
-              <a:buNone/>
-            </a:pPr>
-            <a:r>
-              <a:rPr lang="en-US" sz="1200" b="0">
-                <a:solidFill>
-                  <a:srgbClr val="202b33"/>
-                </a:solidFill>
-                <a:latin typeface="Arial"/>
-                <a:ea typeface="Arial"/>
-                <a:cs typeface="Arial"/>
-              </a:rPr>
-              <a:t xml:space="preserve">After execution: record checks, outcome, correction and frequency</a:t>
-            </a:r>
-            <a:endParaRPr lang="en-US" sz="1200"/>
-          </a:p>
-          <a:p>
-            <a:pPr marL="0" indent="0">
-              <a:lnSpc>
-                <a:spcPts val="1560"/>
-              </a:lnSpc>
-              <a:spcAft>
-                <a:spcPts val="0"/>
-              </a:spcAft>
-              <a:buNone/>
-            </a:pPr>
-            <a:r>
-              <a:rPr lang="en-US" sz="1200" b="0">
-                <a:solidFill>
-                  <a:srgbClr val="202b33"/>
-                </a:solidFill>
-                <a:latin typeface="Arial"/>
-                <a:ea typeface="Arial"/>
-                <a:cs typeface="Arial"/>
-              </a:rPr>
-              <a:t xml:space="preserve"/>
-            </a:r>
-            <a:endParaRPr lang="en-US" sz="1200"/>
-          </a:p>
-          <a:p>
-            <a:pPr marL="0" indent="0">
-              <a:lnSpc>
-                <a:spcPts val="1560"/>
-              </a:lnSpc>
-              <a:spcAft>
-                <a:spcPts val="0"/>
-              </a:spcAft>
-              <a:buNone/>
-            </a:pPr>
-            <a:r>
-              <a:rPr lang="en-US" sz="1200" b="0">
-                <a:solidFill>
-                  <a:srgbClr val="202b33"/>
-                </a:solidFill>
-                <a:latin typeface="Arial"/>
-                <a:ea typeface="Arial"/>
-                <a:cs typeface="Arial"/>
-              </a:rPr>
-              <a:t xml:space="preserve">Generated, executed and verified are different states</a:t>
-            </a:r>
-            <a:endParaRPr lang="en-US" sz="1200"/>
-          </a:p>
-          <a:p>
-            <a:pPr marL="0" indent="0">
-              <a:lnSpc>
-                <a:spcPts val="1560"/>
-              </a:lnSpc>
-              <a:spcAft>
-                <a:spcPts val="0"/>
-              </a:spcAft>
-              <a:buNone/>
-            </a:pPr>
-            <a:r>
-              <a:rPr lang="en-US" sz="1200" b="0">
-                <a:solidFill>
-                  <a:srgbClr val="202b33"/>
-                </a:solidFill>
-                <a:latin typeface="Arial"/>
-                <a:ea typeface="Arial"/>
-                <a:cs typeface="Arial"/>
-              </a:rPr>
-              <a:t xml:space="preserve"/>
-            </a:r>
-            <a:endParaRPr lang="en-US" sz="1200"/>
-          </a:p>
-          <a:p>
-            <a:pPr marL="0" indent="0">
-              <a:lnSpc>
-                <a:spcPts val="1560"/>
-              </a:lnSpc>
-              <a:spcAft>
-                <a:spcPts val="0"/>
-              </a:spcAft>
-              <a:buNone/>
-            </a:pPr>
-            <a:r>
-              <a:rPr lang="en-US" sz="1200" b="0">
-                <a:solidFill>
-                  <a:srgbClr val="202b33"/>
-                </a:solidFill>
-                <a:latin typeface="Arial"/>
-                <a:ea typeface="Arial"/>
-                <a:cs typeface="Arial"/>
-              </a:rPr>
-              <a:t xml:space="preserve">Memory is evidence, never permission</a:t>
-            </a:r>
-            <a:endParaRPr lang="en-US" sz="1200"/>
-          </a:p>
-          <a:p>
-            <a:pPr marL="0" indent="0">
-              <a:lnSpc>
-                <a:spcPts val="1560"/>
-              </a:lnSpc>
-              <a:spcAft>
-                <a:spcPts val="0"/>
-              </a:spcAft>
-              <a:buNone/>
-            </a:pPr>
-            <a:r>
-              <a:rPr lang="en-US" sz="1200" b="0">
-                <a:solidFill>
-                  <a:srgbClr val="202b33"/>
-                </a:solidFill>
-                <a:latin typeface="Arial"/>
-                <a:ea typeface="Arial"/>
-                <a:cs typeface="Arial"/>
-              </a:rPr>
-              <a:t xml:space="preserve"/>
-            </a:r>
-            <a:endParaRPr lang="en-US" sz="1200"/>
-          </a:p>
-          <a:p>
-            <a:pPr marL="0" indent="0">
-              <a:lnSpc>
-                <a:spcPts val="1560"/>
-              </a:lnSpc>
-              <a:spcAft>
-                <a:spcPts val="0"/>
-              </a:spcAft>
-              <a:buNone/>
-            </a:pPr>
-            <a:r>
-              <a:rPr lang="en-US" sz="1200" b="0">
-                <a:solidFill>
-                  <a:srgbClr val="202b33"/>
-                </a:solidFill>
-                <a:latin typeface="Arial"/>
-                <a:ea typeface="Arial"/>
-                <a:cs typeface="Arial"/>
-              </a:rPr>
-              <a:t xml:space="preserve">You do not need the whole agent factory to start. Take one agent that writes SQL, builds reports, runs shell commands or generates scripted API actions. Give it working memory for this job: the goal, constraints, draft and unresolved checks. Give it observational memory across jobs: what it generated, what actually ran, what failed, and what the checks established. Now ask it to consult that history before it hands you the next answer.</a:t>
-            </a:r>
-            <a:endParaRPr lang="en-US" sz="1200"/>
-          </a:p>
-          <a:p>
-            <a:pPr marL="0" indent="0">
-              <a:lnSpc>
-                <a:spcPts val="1560"/>
-              </a:lnSpc>
-              <a:spcAft>
-                <a:spcPts val="0"/>
-              </a:spcAft>
-              <a:buNone/>
-            </a:pPr>
-            <a:r>
-              <a:rPr lang="en-US" sz="1200" b="0">
-                <a:solidFill>
-                  <a:srgbClr val="202b33"/>
-                </a:solidFill>
-                <a:latin typeface="Arial"/>
-                <a:ea typeface="Arial"/>
-                <a:cs typeface="Arial"/>
-              </a:rPr>
-              <a:t xml:space="preserve"/>
-            </a:r>
-            <a:endParaRPr lang="en-US" sz="1200"/>
-          </a:p>
-          <a:p>
-            <a:pPr marL="0" indent="0">
-              <a:lnSpc>
-                <a:spcPts val="1560"/>
-              </a:lnSpc>
-              <a:spcAft>
-                <a:spcPts val="0"/>
-              </a:spcAft>
-              <a:buNone/>
-            </a:pPr>
-            <a:r>
-              <a:rPr lang="en-US" sz="1200" b="0">
-                <a:solidFill>
-                  <a:srgbClr val="202b33"/>
-                </a:solidFill>
-                <a:latin typeface="Arial"/>
-                <a:ea typeface="Arial"/>
-                <a:cs typeface="Arial"/>
-              </a:rPr>
-              <a:t xml:space="preserve">Suppose a reporting query keeps forgetting the tenant filter. It runs perfectly well; it reports the wrong population. An independent preflight check rejects it before dispatch. Record the draft, the failed check, the correction and the eventual result. Next time, retrieve that pattern while the agent is still drafting. Fix the omission before returning the SQL, then run the check again. That is adaptive behavior you can build with one agent and a small log.</a:t>
-            </a:r>
-            <a:endParaRPr lang="en-US" sz="1200"/>
-          </a:p>
-          <a:p>
-            <a:pPr marL="0" indent="0">
-              <a:lnSpc>
-                <a:spcPts val="1560"/>
-              </a:lnSpc>
-              <a:spcAft>
-                <a:spcPts val="0"/>
-              </a:spcAft>
-              <a:buNone/>
-            </a:pPr>
-            <a:r>
-              <a:rPr lang="en-US" sz="1200" b="0">
-                <a:solidFill>
-                  <a:srgbClr val="202b33"/>
-                </a:solidFill>
-                <a:latin typeface="Arial"/>
-                <a:ea typeface="Arial"/>
-                <a:cs typeface="Arial"/>
-              </a:rPr>
-              <a:t xml:space="preserve"/>
-            </a:r>
-            <a:endParaRPr lang="en-US" sz="1200"/>
-          </a:p>
-          <a:p>
-            <a:pPr marL="0" indent="0">
-              <a:lnSpc>
-                <a:spcPts val="1560"/>
-              </a:lnSpc>
-              <a:spcAft>
-                <a:spcPts val="0"/>
-              </a:spcAft>
-              <a:buNone/>
-            </a:pPr>
-            <a:r>
-              <a:rPr lang="en-US" sz="1200" b="0">
-                <a:solidFill>
-                  <a:srgbClr val="202b33"/>
-                </a:solidFill>
-                <a:latin typeface="Arial"/>
-                <a:ea typeface="Arial"/>
-                <a:cs typeface="Arial"/>
-              </a:rPr>
-              <a:t xml:space="preserve">The instruction is simple: before returning generated work, retrieve relevant memory and correct applicable mistakes; after an authorized execution, record the observed outcome and update the pattern counts. If you cannot check something safely, say what remains unverified. Remembered output is untrusted data and grants no new permissions. The copyable prompt and a small record format are in the handout.</a:t>
-            </a:r>
-            <a:endParaRPr lang="en-US" sz="1200"/>
-          </a:p>
-          <a:p>
-            <a:pPr marL="0" indent="0">
-              <a:lnSpc>
-                <a:spcPts val="1560"/>
-              </a:lnSpc>
-              <a:spcAft>
-                <a:spcPts val="0"/>
-              </a:spcAft>
-              <a:buNone/>
-            </a:pPr>
-            <a:r>
-              <a:rPr lang="en-US" sz="1200" b="0">
-                <a:solidFill>
-                  <a:srgbClr val="202b33"/>
-                </a:solidFill>
-                <a:latin typeface="Arial"/>
-                <a:ea typeface="Arial"/>
-                <a:cs typeface="Arial"/>
-              </a:rPr>
-              <a:t xml:space="preserve"/>
-            </a:r>
-            <a:endParaRPr lang="en-US" sz="1200"/>
-          </a:p>
-          <a:p>
-            <a:pPr marL="0" indent="0">
-              <a:lnSpc>
-                <a:spcPts val="1560"/>
-              </a:lnSpc>
-              <a:spcAft>
-                <a:spcPts val="0"/>
-              </a:spcAft>
-              <a:buNone/>
-            </a:pPr>
-            <a:r>
-              <a:rPr lang="en-US" sz="1200" b="0">
-                <a:solidFill>
-                  <a:srgbClr val="202b33"/>
-                </a:solidFill>
-                <a:latin typeface="Arial"/>
-                <a:ea typeface="Arial"/>
-                <a:cs typeface="Arial"/>
-              </a:rPr>
-              <a:t xml:space="preserve">As patterns repeat, turn the reliable ones into tested templates and adapters. The runtime agent learns which evidence to consult; the offline improvement loop evaluates changes to the reusable procedure. Once the known case is covered by code, it need not spend another model call rediscovering the rule.</a:t>
-            </a:r>
-            <a:endParaRPr lang="en-US" sz="1200"/>
-          </a:p>
-          <a:p>
-            <a:pPr marL="0" indent="0">
-              <a:lnSpc>
-                <a:spcPts val="1560"/>
-              </a:lnSpc>
-              <a:spcAft>
-                <a:spcPts val="0"/>
-              </a:spcAft>
-              <a:buNone/>
-            </a:pPr>
-            <a:r>
-              <a:rPr lang="en-US" sz="1200" b="0">
-                <a:solidFill>
-                  <a:srgbClr val="202b33"/>
-                </a:solidFill>
-                <a:latin typeface="Arial"/>
-                <a:ea typeface="Arial"/>
-                <a:cs typeface="Arial"/>
-              </a:rPr>
-              <a:t xml:space="preserve"/>
-            </a:r>
-            <a:endParaRPr lang="en-US" sz="1200"/>
-          </a:p>
-          <a:p>
-            <a:pPr marL="0" indent="0">
-              <a:lnSpc>
-                <a:spcPts val="1560"/>
-              </a:lnSpc>
-              <a:spcAft>
-                <a:spcPts val="0"/>
-              </a:spcAft>
-              <a:buNone/>
-            </a:pPr>
-            <a:r>
-              <a:rPr lang="en-US" sz="1200" b="0">
-                <a:solidFill>
-                  <a:srgbClr val="202b33"/>
-                </a:solidFill>
-                <a:latin typeface="Arial"/>
-                <a:ea typeface="Arial"/>
-                <a:cs typeface="Arial"/>
-              </a:rPr>
-              <a:t xml:space="preserve"/>
-            </a:r>
-            <a:endParaRPr lang="en-US" sz="1200"/>
-          </a:p>
-          <a:p>
-            <a:pPr marL="0" indent="0">
-              <a:lnSpc>
-                <a:spcPts val="1560"/>
-              </a:lnSpc>
-              <a:spcAft>
-                <a:spcPts val="0"/>
-              </a:spcAft>
-              <a:buNone/>
-            </a:pPr>
-            <a:r>
-              <a:rPr lang="en-US" sz="1200" b="0">
-                <a:solidFill>
-                  <a:srgbClr val="202b33"/>
-                </a:solidFill>
-                <a:latin typeface="Arial"/>
-                <a:ea typeface="Arial"/>
-                <a:cs typeface="Arial"/>
-              </a:rPr>
-              <a:t xml:space="preserve"/>
-            </a:r>
-            <a:endParaRPr lang="en-US" sz="1200"/>
-          </a:p>
-          <a:p>
-            <a:pPr marL="0" indent="0">
-              <a:lnSpc>
-                <a:spcPts val="1560"/>
-              </a:lnSpc>
-              <a:spcAft>
-                <a:spcPts val="0"/>
-              </a:spcAft>
-              <a:buNone/>
-            </a:pPr>
-            <a:r>
-              <a:rPr lang="en-US" sz="1200" b="0">
-                <a:solidFill>
-                  <a:srgbClr val="202b33"/>
-                </a:solidFill>
-                <a:latin typeface="Arial"/>
-                <a:ea typeface="Arial"/>
-                <a:cs typeface="Arial"/>
-              </a:rPr>
-              <a:t xml:space="preserve">Show the prompt in memory-pattern.md. Ask which observation proves the query ran and which proves it answered the right question. Use the tenant-filter example; no live execution is needed.</a:t>
-            </a:r>
-            <a:endParaRPr lang="en-US" sz="1200"/>
-          </a:p>
-          <a:p>
-            <a:pPr marL="0" indent="0">
-              <a:lnSpc>
-                <a:spcPts val="1560"/>
-              </a:lnSpc>
-              <a:spcAft>
-                <a:spcPts val="0"/>
-              </a:spcAft>
-              <a:buNone/>
-            </a:pPr>
-            <a:r>
-              <a:rPr lang="en-US" sz="1200" b="0">
-                <a:solidFill>
-                  <a:srgbClr val="202b33"/>
-                </a:solidFill>
-                <a:latin typeface="Arial"/>
-                <a:ea typeface="Arial"/>
-                <a:cs typeface="Arial"/>
-              </a:rPr>
-              <a:t xml:space="preserve"/>
-            </a:r>
-            <a:endParaRPr lang="en-US" sz="1200"/>
-          </a:p>
-          <a:p>
-            <a:pPr marL="0" indent="0">
-              <a:lnSpc>
-                <a:spcPts val="1560"/>
-              </a:lnSpc>
-              <a:spcAft>
-                <a:spcPts val="0"/>
-              </a:spcAft>
-              <a:buNone/>
-            </a:pPr>
-            <a:r>
-              <a:rPr lang="en-US" sz="1200" b="0">
-                <a:solidFill>
-                  <a:srgbClr val="202b33"/>
-                </a:solidFill>
-                <a:latin typeface="Arial"/>
-                <a:ea typeface="Arial"/>
-                <a:cs typeface="Arial"/>
-              </a:rPr>
-              <a:t xml:space="preserve"/>
-            </a:r>
-            <a:endParaRPr lang="en-US" sz="1200"/>
-          </a:p>
-        </p:txBody>
-      </p:sp>
-    </p:spTree>
-  </p:cSld>
-  <p:clrMapOvr>
-    <a:masterClrMapping/>
-  </p:clrMapOvr>
-</p:notes>
-</file>
-
-<file path=ppt/notesSlides/notesSlide8.xml><?xml version="1.0" encoding="utf-8"?>
-<p:notes xmlns:a="http://schemas.openxmlformats.org/drawingml/2006/main" xmlns:r="http://schemas.openxmlformats.org/officeDocument/2006/relationships" xmlns:p="http://schemas.openxmlformats.org/presentationml/2006/main">
-  <p:cSld>
-    <p:spTree>
-      <p:nvGrpSpPr>
-        <p:cNvPr id="1" name=""/>
-        <p:cNvGrpSpPr/>
-        <p:nvPr/>
-      </p:nvGrpSpPr>
-      <p:grpSpPr>
-        <a:xfrm>
-          <a:off x="0" y="0"/>
-          <a:ext cx="0" cy="0"/>
-          <a:chOff x="0" y="0"/>
-          <a:chExt cx="0" cy="0"/>
-        </a:xfrm>
-      </p:grpSpPr>
-      <p:sp>
-        <p:nvSpPr>
-          <p:cNvPr id="2" name="Presenter notes"/>
-          <p:cNvSpPr txBox="1"/>
-          <p:nvPr>
-            <p:ph type="body" idx="1"/>
-          </p:nvPr>
-        </p:nvSpPr>
-        <p:spPr>
-          <a:xfrm>
-            <a:off x="457200" y="1428750"/>
-            <a:ext cx="5715000" cy="6667500"/>
-          </a:xfrm>
-        </p:spPr>
-        <p:txBody>
-          <a:bodyPr/>
-          <a:lstStyle/>
-          <a:p>
-            <a:pPr marL="0" indent="0">
-              <a:lnSpc>
-                <a:spcPts val="1560"/>
-              </a:lnSpc>
-              <a:spcAft>
-                <a:spcPts val="0"/>
-              </a:spcAft>
-              <a:buNone/>
-            </a:pPr>
-            <a:r>
-              <a:rPr lang="en-US" sz="1200" b="0">
-                <a:solidFill>
-                  <a:srgbClr val="202b33"/>
-                </a:solidFill>
-                <a:latin typeface="Arial"/>
-                <a:ea typeface="Arial"/>
-                <a:cs typeface="Arial"/>
-              </a:rPr>
-              <a:t xml:space="preserve">Adaptive, agentic apps</a:t>
-            </a:r>
-            <a:endParaRPr lang="en-US" sz="1200"/>
-          </a:p>
-          <a:p>
-            <a:pPr marL="0" indent="0">
-              <a:lnSpc>
-                <a:spcPts val="1560"/>
-              </a:lnSpc>
-              <a:spcAft>
-                <a:spcPts val="0"/>
-              </a:spcAft>
-              <a:buNone/>
-            </a:pPr>
-            <a:r>
-              <a:rPr lang="en-US" sz="1200" b="0">
-                <a:solidFill>
-                  <a:srgbClr val="202b33"/>
-                </a:solidFill>
-                <a:latin typeface="Arial"/>
-                <a:ea typeface="Arial"/>
-                <a:cs typeface="Arial"/>
-              </a:rPr>
-              <a:t xml:space="preserve"/>
-            </a:r>
-            <a:endParaRPr lang="en-US" sz="1200"/>
-          </a:p>
-          <a:p>
-            <a:pPr marL="0" indent="0">
-              <a:lnSpc>
-                <a:spcPts val="1560"/>
-              </a:lnSpc>
-              <a:spcAft>
-                <a:spcPts val="0"/>
-              </a:spcAft>
-              <a:buNone/>
-            </a:pPr>
-            <a:r>
-              <a:rPr lang="en-US" sz="1200" b="0">
-                <a:solidFill>
-                  <a:srgbClr val="202b33"/>
-                </a:solidFill>
-                <a:latin typeface="Arial"/>
-                <a:ea typeface="Arial"/>
-                <a:cs typeface="Arial"/>
-              </a:rPr>
-              <a:t xml:space="preserve">Source slide 15. 14:00 to 15:00</a:t>
+              <a:t xml:space="preserve">Source slide 15. 12:45 to 15:00</a:t>
             </a:r>
             <a:endParaRPr lang="en-US" sz="1200"/>
           </a:p>
@@ -4158,52 +3354,6 @@
                 <a:cs typeface="Arial"/>
               </a:rPr>
               <a:t xml:space="preserve">Remember the known case</a:t>
-            </a:r>
-            <a:endParaRPr lang="en-US" sz="1200"/>
-          </a:p>
-          <a:p>
-            <a:pPr marL="0" indent="0">
-              <a:lnSpc>
-                <a:spcPts val="1560"/>
-              </a:lnSpc>
-              <a:spcAft>
-                <a:spcPts val="0"/>
-              </a:spcAft>
-              <a:buNone/>
-            </a:pPr>
-            <a:r>
-              <a:rPr lang="en-US" sz="1200" b="0">
-                <a:solidFill>
-                  <a:srgbClr val="202b33"/>
-                </a:solidFill>
-                <a:latin typeface="Arial"/>
-                <a:ea typeface="Arial"/>
-                <a:cs typeface="Arial"/>
-              </a:rPr>
-              <a:t xml:space="preserve"/>
-            </a:r>
-            <a:endParaRPr lang="en-US" sz="1200"/>
-          </a:p>
-          <a:p>
-            <a:pPr marL="0" indent="0">
-              <a:lnSpc>
-                <a:spcPts val="1560"/>
-              </a:lnSpc>
-              <a:spcAft>
-                <a:spcPts val="0"/>
-              </a:spcAft>
-              <a:buNone/>
-            </a:pPr>
-            <a:r>
-              <a:rPr lang="en-US" sz="1200" b="0">
-                <a:solidFill>
-                  <a:srgbClr val="202b33"/>
-                </a:solidFill>
-                <a:latin typeface="Arial"/>
-                <a:ea typeface="Arial"/>
-                <a:cs typeface="Arial"/>
-              </a:rPr>
-              <a:t xml:space="preserve">Return to the field that changed overnight. We did not predict its spelling. We did define what had to stay true, what evidence a repair needed, which tools this one job could have, and how far the app could go without us.</a:t>
             </a:r>
             <a:endParaRPr lang="en-US" sz="1200"/>
           </a:p>
@@ -4855,7 +4005,7 @@
                 <a:ea typeface="Arial"/>
                 <a:cs typeface="Arial"/>
               </a:rPr>
-              <a:t xml:space="preserve">02 / 08    SOURCE SLIDE 3</a:t>
+              <a:t xml:space="preserve">02 / 07    SOURCE SLIDE 3</a:t>
             </a:r>
             <a:endParaRPr lang="en-US" sz="1350"/>
           </a:p>
@@ -5139,7 +4289,7 @@
                 <a:ea typeface="Arial"/>
                 <a:cs typeface="Arial"/>
               </a:rPr>
-              <a:t xml:space="preserve">03 / 08    SOURCE SLIDE 4</a:t>
+              <a:t xml:space="preserve">03 / 07    SOURCE SLIDE 4</a:t>
             </a:r>
             <a:endParaRPr lang="en-US" sz="1350"/>
           </a:p>
@@ -5423,7 +4573,7 @@
                 <a:ea typeface="Arial"/>
                 <a:cs typeface="Arial"/>
               </a:rPr>
-              <a:t xml:space="preserve">04 / 08    SOURCE SLIDE 5</a:t>
+              <a:t xml:space="preserve">04 / 07    SOURCE SLIDE 5</a:t>
             </a:r>
             <a:endParaRPr lang="en-US" sz="1350"/>
           </a:p>
@@ -5707,7 +4857,7 @@
                 <a:ea typeface="Arial"/>
                 <a:cs typeface="Arial"/>
               </a:rPr>
-              <a:t xml:space="preserve">05 / 08    SOURCE SLIDE 6</a:t>
+              <a:t xml:space="preserve">05 / 07    SOURCE SLIDE 6</a:t>
             </a:r>
             <a:endParaRPr lang="en-US" sz="1350"/>
           </a:p>
@@ -5991,7 +5141,7 @@
                 <a:ea typeface="Arial"/>
                 <a:cs typeface="Arial"/>
               </a:rPr>
-              <a:t xml:space="preserve">06 / 08    SOURCE SLIDE 10</a:t>
+              <a:t xml:space="preserve">06 / 07    SOURCE SLIDE 10</a:t>
             </a:r>
             <a:endParaRPr lang="en-US" sz="1350"/>
           </a:p>
@@ -6275,7 +5425,7 @@
                 <a:ea typeface="Arial"/>
                 <a:cs typeface="Arial"/>
               </a:rPr>
-              <a:t xml:space="preserve">07 / 08    SOURCE SLIDE 14</a:t>
+              <a:t xml:space="preserve">07 / 07    SOURCE SLIDE 15</a:t>
             </a:r>
             <a:endParaRPr lang="en-US" sz="1350"/>
           </a:p>
@@ -6324,7 +5474,7 @@
                 <a:ea typeface="Arial"/>
                 <a:cs typeface="Arial"/>
               </a:rPr>
-              <a:t xml:space="preserve">Start smaller: remember what happened</a:t>
+              <a:t xml:space="preserve">The next surprise should cost less</a:t>
             </a:r>
             <a:endParaRPr lang="en-US" sz="3900"/>
           </a:p>
@@ -6388,696 +5538,6 @@
         <p:spPr>
           <a:xfrm>
             <a:off x="2000250" y="2771775"/>
-            <a:ext cx="11029950" cy="1059180"/>
-          </a:xfrm>
-          <a:prstGeom prst="rect">
-            <a:avLst/>
-          </a:prstGeom>
-          <a:noFill/>
-          <a:ln>
-            <a:noFill/>
-          </a:ln>
-        </p:spPr>
-        <p:txBody>
-          <a:bodyPr wrap="none" lIns="0" tIns="0" rIns="0" bIns="0" anchor="t">
-            <a:noAutofit/>
-          </a:bodyPr>
-          <a:lstStyle/>
-          <a:p>
-            <a:pPr marL="0" indent="0">
-              <a:lnSpc>
-                <a:spcPts val="4095"/>
-              </a:lnSpc>
-              <a:spcAft>
-                <a:spcPts val="0"/>
-              </a:spcAft>
-              <a:buNone/>
-            </a:pPr>
-            <a:r>
-              <a:rPr lang="en-US" sz="3150" b="0">
-                <a:solidFill>
-                  <a:srgbClr val="F5F1E9"/>
-                </a:solidFill>
-                <a:latin typeface="Arial"/>
-                <a:ea typeface="Arial"/>
-                <a:cs typeface="Arial"/>
-              </a:rPr>
-              <a:t xml:space="preserve">Before returning: check relevant memory and correct</a:t>
-            </a:r>
-            <a:endParaRPr lang="en-US" sz="3150"/>
-          </a:p>
-          <a:p>
-            <a:pPr marL="0" indent="0">
-              <a:lnSpc>
-                <a:spcPts val="4095"/>
-              </a:lnSpc>
-              <a:spcAft>
-                <a:spcPts val="0"/>
-              </a:spcAft>
-              <a:buNone/>
-            </a:pPr>
-            <a:r>
-              <a:rPr lang="en-US" sz="3150" b="0">
-                <a:solidFill>
-                  <a:srgbClr val="F5F1E9"/>
-                </a:solidFill>
-                <a:latin typeface="Arial"/>
-                <a:ea typeface="Arial"/>
-                <a:cs typeface="Arial"/>
-              </a:rPr>
-              <a:t xml:space="preserve">known mistakes</a:t>
-            </a:r>
-            <a:endParaRPr lang="en-US" sz="3150"/>
-          </a:p>
-        </p:txBody>
-      </p:sp>
-      <p:sp>
-        <p:nvSpPr>
-          <p:cNvPr id="6" name="Text 6"/>
-          <p:cNvSpPr txBox="1"/>
-          <p:nvPr/>
-        </p:nvSpPr>
-        <p:spPr>
-          <a:xfrm>
-            <a:off x="685800" y="4078605"/>
-            <a:ext cx="904875" cy="476250"/>
-          </a:xfrm>
-          <a:prstGeom prst="rect">
-            <a:avLst/>
-          </a:prstGeom>
-          <a:noFill/>
-          <a:ln>
-            <a:noFill/>
-          </a:ln>
-        </p:spPr>
-        <p:txBody>
-          <a:bodyPr wrap="none" lIns="0" tIns="0" rIns="0" bIns="0" anchor="t">
-            <a:noAutofit/>
-          </a:bodyPr>
-          <a:lstStyle/>
-          <a:p>
-            <a:pPr marL="0" indent="0">
-              <a:lnSpc>
-                <a:spcPts val="2438"/>
-              </a:lnSpc>
-              <a:spcAft>
-                <a:spcPts val="0"/>
-              </a:spcAft>
-              <a:buNone/>
-            </a:pPr>
-            <a:r>
-              <a:rPr lang="en-US" sz="1875" b="0">
-                <a:solidFill>
-                  <a:srgbClr val="A4D2C4"/>
-                </a:solidFill>
-                <a:latin typeface="Arial"/>
-                <a:ea typeface="Arial"/>
-                <a:cs typeface="Arial"/>
-              </a:rPr>
-              <a:t xml:space="preserve">02</a:t>
-            </a:r>
-            <a:endParaRPr lang="en-US" sz="1875"/>
-          </a:p>
-        </p:txBody>
-      </p:sp>
-      <p:sp>
-        <p:nvSpPr>
-          <p:cNvPr id="7" name="Text 7"/>
-          <p:cNvSpPr txBox="1"/>
-          <p:nvPr/>
-        </p:nvSpPr>
-        <p:spPr>
-          <a:xfrm>
-            <a:off x="2000250" y="4078605"/>
-            <a:ext cx="11029950" cy="1059180"/>
-          </a:xfrm>
-          <a:prstGeom prst="rect">
-            <a:avLst/>
-          </a:prstGeom>
-          <a:noFill/>
-          <a:ln>
-            <a:noFill/>
-          </a:ln>
-        </p:spPr>
-        <p:txBody>
-          <a:bodyPr wrap="none" lIns="0" tIns="0" rIns="0" bIns="0" anchor="t">
-            <a:noAutofit/>
-          </a:bodyPr>
-          <a:lstStyle/>
-          <a:p>
-            <a:pPr marL="0" indent="0">
-              <a:lnSpc>
-                <a:spcPts val="4095"/>
-              </a:lnSpc>
-              <a:spcAft>
-                <a:spcPts val="0"/>
-              </a:spcAft>
-              <a:buNone/>
-            </a:pPr>
-            <a:r>
-              <a:rPr lang="en-US" sz="3150" b="0">
-                <a:solidFill>
-                  <a:srgbClr val="F5F1E9"/>
-                </a:solidFill>
-                <a:latin typeface="Arial"/>
-                <a:ea typeface="Arial"/>
-                <a:cs typeface="Arial"/>
-              </a:rPr>
-              <a:t xml:space="preserve">After execution: record checks, outcome, correction</a:t>
-            </a:r>
-            <a:endParaRPr lang="en-US" sz="3150"/>
-          </a:p>
-          <a:p>
-            <a:pPr marL="0" indent="0">
-              <a:lnSpc>
-                <a:spcPts val="4095"/>
-              </a:lnSpc>
-              <a:spcAft>
-                <a:spcPts val="0"/>
-              </a:spcAft>
-              <a:buNone/>
-            </a:pPr>
-            <a:r>
-              <a:rPr lang="en-US" sz="3150" b="0">
-                <a:solidFill>
-                  <a:srgbClr val="F5F1E9"/>
-                </a:solidFill>
-                <a:latin typeface="Arial"/>
-                <a:ea typeface="Arial"/>
-                <a:cs typeface="Arial"/>
-              </a:rPr>
-              <a:t xml:space="preserve">and frequency</a:t>
-            </a:r>
-            <a:endParaRPr lang="en-US" sz="3150"/>
-          </a:p>
-        </p:txBody>
-      </p:sp>
-      <p:sp>
-        <p:nvSpPr>
-          <p:cNvPr id="8" name="Text 8"/>
-          <p:cNvSpPr txBox="1"/>
-          <p:nvPr/>
-        </p:nvSpPr>
-        <p:spPr>
-          <a:xfrm>
-            <a:off x="685800" y="5385435"/>
-            <a:ext cx="904875" cy="476250"/>
-          </a:xfrm>
-          <a:prstGeom prst="rect">
-            <a:avLst/>
-          </a:prstGeom>
-          <a:noFill/>
-          <a:ln>
-            <a:noFill/>
-          </a:ln>
-        </p:spPr>
-        <p:txBody>
-          <a:bodyPr wrap="none" lIns="0" tIns="0" rIns="0" bIns="0" anchor="t">
-            <a:noAutofit/>
-          </a:bodyPr>
-          <a:lstStyle/>
-          <a:p>
-            <a:pPr marL="0" indent="0">
-              <a:lnSpc>
-                <a:spcPts val="2438"/>
-              </a:lnSpc>
-              <a:spcAft>
-                <a:spcPts val="0"/>
-              </a:spcAft>
-              <a:buNone/>
-            </a:pPr>
-            <a:r>
-              <a:rPr lang="en-US" sz="1875" b="0">
-                <a:solidFill>
-                  <a:srgbClr val="A4D2C4"/>
-                </a:solidFill>
-                <a:latin typeface="Arial"/>
-                <a:ea typeface="Arial"/>
-                <a:cs typeface="Arial"/>
-              </a:rPr>
-              <a:t xml:space="preserve">03</a:t>
-            </a:r>
-            <a:endParaRPr lang="en-US" sz="1875"/>
-          </a:p>
-        </p:txBody>
-      </p:sp>
-      <p:sp>
-        <p:nvSpPr>
-          <p:cNvPr id="9" name="Text 9"/>
-          <p:cNvSpPr txBox="1"/>
-          <p:nvPr/>
-        </p:nvSpPr>
-        <p:spPr>
-          <a:xfrm>
-            <a:off x="2000250" y="5385435"/>
-            <a:ext cx="11029950" cy="1059180"/>
-          </a:xfrm>
-          <a:prstGeom prst="rect">
-            <a:avLst/>
-          </a:prstGeom>
-          <a:noFill/>
-          <a:ln>
-            <a:noFill/>
-          </a:ln>
-        </p:spPr>
-        <p:txBody>
-          <a:bodyPr wrap="none" lIns="0" tIns="0" rIns="0" bIns="0" anchor="t">
-            <a:noAutofit/>
-          </a:bodyPr>
-          <a:lstStyle/>
-          <a:p>
-            <a:pPr marL="0" indent="0">
-              <a:lnSpc>
-                <a:spcPts val="4095"/>
-              </a:lnSpc>
-              <a:spcAft>
-                <a:spcPts val="0"/>
-              </a:spcAft>
-              <a:buNone/>
-            </a:pPr>
-            <a:r>
-              <a:rPr lang="en-US" sz="3150" b="0">
-                <a:solidFill>
-                  <a:srgbClr val="F5F1E9"/>
-                </a:solidFill>
-                <a:latin typeface="Arial"/>
-                <a:ea typeface="Arial"/>
-                <a:cs typeface="Arial"/>
-              </a:rPr>
-              <a:t xml:space="preserve">Generated, executed and verified are different</a:t>
-            </a:r>
-            <a:endParaRPr lang="en-US" sz="3150"/>
-          </a:p>
-          <a:p>
-            <a:pPr marL="0" indent="0">
-              <a:lnSpc>
-                <a:spcPts val="4095"/>
-              </a:lnSpc>
-              <a:spcAft>
-                <a:spcPts val="0"/>
-              </a:spcAft>
-              <a:buNone/>
-            </a:pPr>
-            <a:r>
-              <a:rPr lang="en-US" sz="3150" b="0">
-                <a:solidFill>
-                  <a:srgbClr val="F5F1E9"/>
-                </a:solidFill>
-                <a:latin typeface="Arial"/>
-                <a:ea typeface="Arial"/>
-                <a:cs typeface="Arial"/>
-              </a:rPr>
-              <a:t xml:space="preserve">states</a:t>
-            </a:r>
-            <a:endParaRPr lang="en-US" sz="3150"/>
-          </a:p>
-        </p:txBody>
-      </p:sp>
-      <p:sp>
-        <p:nvSpPr>
-          <p:cNvPr id="10" name="Text 10"/>
-          <p:cNvSpPr txBox="1"/>
-          <p:nvPr/>
-        </p:nvSpPr>
-        <p:spPr>
-          <a:xfrm>
-            <a:off x="685800" y="6692265"/>
-            <a:ext cx="904875" cy="476250"/>
-          </a:xfrm>
-          <a:prstGeom prst="rect">
-            <a:avLst/>
-          </a:prstGeom>
-          <a:noFill/>
-          <a:ln>
-            <a:noFill/>
-          </a:ln>
-        </p:spPr>
-        <p:txBody>
-          <a:bodyPr wrap="none" lIns="0" tIns="0" rIns="0" bIns="0" anchor="t">
-            <a:noAutofit/>
-          </a:bodyPr>
-          <a:lstStyle/>
-          <a:p>
-            <a:pPr marL="0" indent="0">
-              <a:lnSpc>
-                <a:spcPts val="2438"/>
-              </a:lnSpc>
-              <a:spcAft>
-                <a:spcPts val="0"/>
-              </a:spcAft>
-              <a:buNone/>
-            </a:pPr>
-            <a:r>
-              <a:rPr lang="en-US" sz="1875" b="0">
-                <a:solidFill>
-                  <a:srgbClr val="A4D2C4"/>
-                </a:solidFill>
-                <a:latin typeface="Arial"/>
-                <a:ea typeface="Arial"/>
-                <a:cs typeface="Arial"/>
-              </a:rPr>
-              <a:t xml:space="preserve">04</a:t>
-            </a:r>
-            <a:endParaRPr lang="en-US" sz="1875"/>
-          </a:p>
-        </p:txBody>
-      </p:sp>
-      <p:sp>
-        <p:nvSpPr>
-          <p:cNvPr id="11" name="Text 11"/>
-          <p:cNvSpPr txBox="1"/>
-          <p:nvPr/>
-        </p:nvSpPr>
-        <p:spPr>
-          <a:xfrm>
-            <a:off x="2000250" y="6692265"/>
-            <a:ext cx="11029950" cy="539115"/>
-          </a:xfrm>
-          <a:prstGeom prst="rect">
-            <a:avLst/>
-          </a:prstGeom>
-          <a:noFill/>
-          <a:ln>
-            <a:noFill/>
-          </a:ln>
-        </p:spPr>
-        <p:txBody>
-          <a:bodyPr wrap="none" lIns="0" tIns="0" rIns="0" bIns="0" anchor="t">
-            <a:noAutofit/>
-          </a:bodyPr>
-          <a:lstStyle/>
-          <a:p>
-            <a:pPr marL="0" indent="0">
-              <a:lnSpc>
-                <a:spcPts val="4095"/>
-              </a:lnSpc>
-              <a:spcAft>
-                <a:spcPts val="0"/>
-              </a:spcAft>
-              <a:buNone/>
-            </a:pPr>
-            <a:r>
-              <a:rPr lang="en-US" sz="3150" b="0">
-                <a:solidFill>
-                  <a:srgbClr val="F5F1E9"/>
-                </a:solidFill>
-                <a:latin typeface="Arial"/>
-                <a:ea typeface="Arial"/>
-                <a:cs typeface="Arial"/>
-              </a:rPr>
-              <a:t xml:space="preserve">Memory is evidence, never permission</a:t>
-            </a:r>
-            <a:endParaRPr lang="en-US" sz="3150"/>
-          </a:p>
-        </p:txBody>
-      </p:sp>
-      <p:sp>
-        <p:nvSpPr>
-          <p:cNvPr id="12" name="Text 12"/>
-          <p:cNvSpPr txBox="1"/>
-          <p:nvPr/>
-        </p:nvSpPr>
-        <p:spPr>
-          <a:xfrm>
-            <a:off x="457200" y="8286750"/>
-            <a:ext cx="12477750" cy="190500"/>
-          </a:xfrm>
-          <a:prstGeom prst="rect">
-            <a:avLst/>
-          </a:prstGeom>
-          <a:noFill/>
-          <a:ln>
-            <a:noFill/>
-          </a:ln>
-        </p:spPr>
-        <p:txBody>
-          <a:bodyPr wrap="none" lIns="0" tIns="0" rIns="0" bIns="0" anchor="t">
-            <a:noAutofit/>
-          </a:bodyPr>
-          <a:lstStyle/>
-          <a:p>
-            <a:pPr marL="0" indent="0">
-              <a:lnSpc>
-                <a:spcPts val="1268"/>
-              </a:lnSpc>
-              <a:spcAft>
-                <a:spcPts val="0"/>
-              </a:spcAft>
-              <a:buNone/>
-            </a:pPr>
-            <a:r>
-              <a:rPr lang="en-US" sz="975" b="0">
-                <a:solidFill>
-                  <a:srgbClr val="BEC9C6"/>
-                </a:solidFill>
-                <a:latin typeface="Arial"/>
-                <a:ea typeface="Arial"/>
-                <a:cs typeface="Arial"/>
-              </a:rPr>
-              <a:t xml:space="preserve">Adaptive, agentic apps</a:t>
-            </a:r>
-            <a:endParaRPr lang="en-US" sz="975"/>
-          </a:p>
-        </p:txBody>
-      </p:sp>
-      <p:sp>
-        <p:nvSpPr>
-          <p:cNvPr id="13" name="Text 13"/>
-          <p:cNvSpPr txBox="1"/>
-          <p:nvPr/>
-        </p:nvSpPr>
-        <p:spPr>
-          <a:xfrm>
-            <a:off x="13049250" y="8286750"/>
-            <a:ext cx="238125" cy="190500"/>
-          </a:xfrm>
-          <a:prstGeom prst="rect">
-            <a:avLst/>
-          </a:prstGeom>
-          <a:noFill/>
-          <a:ln>
-            <a:noFill/>
-          </a:ln>
-        </p:spPr>
-        <p:txBody>
-          <a:bodyPr wrap="none" lIns="0" tIns="0" rIns="0" bIns="0" anchor="t">
-            <a:noAutofit/>
-          </a:bodyPr>
-          <a:lstStyle/>
-          <a:p>
-            <a:pPr marL="0" indent="0">
-              <a:lnSpc>
-                <a:spcPts val="1268"/>
-              </a:lnSpc>
-              <a:spcAft>
-                <a:spcPts val="0"/>
-              </a:spcAft>
-              <a:buNone/>
-            </a:pPr>
-            <a:r>
-              <a:rPr lang="en-US" sz="975" b="0">
-                <a:solidFill>
-                  <a:srgbClr val="BEC9C6"/>
-                </a:solidFill>
-                <a:latin typeface="Arial"/>
-                <a:ea typeface="Arial"/>
-                <a:cs typeface="Arial"/>
-              </a:rPr>
-              <a:t xml:space="preserve">7</a:t>
-            </a:r>
-            <a:endParaRPr lang="en-US" sz="975"/>
-          </a:p>
-        </p:txBody>
-      </p:sp>
-    </p:spTree>
-  </p:cSld>
-  <p:clrMapOvr>
-    <a:masterClrMapping/>
-  </p:clrMapOvr>
-</p:sld>
-</file>
-
-<file path=ppt/slides/slide8.xml><?xml version="1.0" encoding="utf-8"?>
-<p:sld xmlns:a="http://schemas.openxmlformats.org/drawingml/2006/main" xmlns:r="http://schemas.openxmlformats.org/officeDocument/2006/relationships" xmlns:p="http://schemas.openxmlformats.org/presentationml/2006/main">
-  <p:cSld name="Slide 8">
-    <p:bg>
-      <p:bgPr>
-        <a:solidFill>
-          <a:srgbClr val="122323"/>
-        </a:solidFill>
-        <a:effectLst/>
-      </p:bgPr>
-    </p:bg>
-    <p:spTree>
-      <p:nvGrpSpPr>
-        <p:cNvPr id="1" name=""/>
-        <p:cNvGrpSpPr/>
-        <p:nvPr/>
-      </p:nvGrpSpPr>
-      <p:grpSpPr>
-        <a:xfrm>
-          <a:off x="0" y="0"/>
-          <a:ext cx="0" cy="0"/>
-          <a:chOff x="0" y="0"/>
-          <a:chExt cx="0" cy="0"/>
-        </a:xfrm>
-      </p:grpSpPr>
-      <p:sp>
-        <p:nvSpPr>
-          <p:cNvPr id="2" name="Text 2"/>
-          <p:cNvSpPr txBox="1"/>
-          <p:nvPr/>
-        </p:nvSpPr>
-        <p:spPr>
-          <a:xfrm>
-            <a:off x="685800" y="381000"/>
-            <a:ext cx="12344400" cy="457200"/>
-          </a:xfrm>
-          <a:prstGeom prst="rect">
-            <a:avLst/>
-          </a:prstGeom>
-          <a:noFill/>
-          <a:ln>
-            <a:noFill/>
-          </a:ln>
-        </p:spPr>
-        <p:txBody>
-          <a:bodyPr wrap="none" lIns="0" tIns="0" rIns="0" bIns="0" anchor="t">
-            <a:noAutofit/>
-          </a:bodyPr>
-          <a:lstStyle/>
-          <a:p>
-            <a:pPr marL="0" indent="0">
-              <a:lnSpc>
-                <a:spcPts val="1755"/>
-              </a:lnSpc>
-              <a:spcAft>
-                <a:spcPts val="0"/>
-              </a:spcAft>
-              <a:buNone/>
-            </a:pPr>
-            <a:r>
-              <a:rPr lang="en-US" sz="1350" b="1">
-                <a:solidFill>
-                  <a:srgbClr val="A4D2C4"/>
-                </a:solidFill>
-                <a:latin typeface="Arial"/>
-                <a:ea typeface="Arial"/>
-                <a:cs typeface="Arial"/>
-              </a:rPr>
-              <a:t xml:space="preserve">08 / 08    SOURCE SLIDE 15</a:t>
-            </a:r>
-            <a:endParaRPr lang="en-US" sz="1350"/>
-          </a:p>
-        </p:txBody>
-      </p:sp>
-      <p:sp>
-        <p:nvSpPr>
-          <p:cNvPr id="3" name="Text 3"/>
-          <p:cNvSpPr txBox="1"/>
-          <p:nvPr/>
-        </p:nvSpPr>
-        <p:spPr>
-          <a:xfrm>
-            <a:off x="685800" y="1057275"/>
-            <a:ext cx="12344400" cy="1381125"/>
-          </a:xfrm>
-          <a:prstGeom prst="rect">
-            <a:avLst/>
-          </a:prstGeom>
-          <a:noFill/>
-          <a:ln>
-            <a:noFill/>
-          </a:ln>
-        </p:spPr>
-        <p:txBody>
-          <a:bodyPr wrap="none" lIns="0" tIns="0" rIns="0" bIns="0" anchor="t">
-            <a:noAutofit/>
-          </a:bodyPr>
-          <a:lstStyle/>
-          <a:p>
-            <a:pPr marL="0" indent="0">
-              <a:lnSpc>
-                <a:spcPts val="4680"/>
-              </a:lnSpc>
-              <a:spcAft>
-                <a:spcPts val="0"/>
-              </a:spcAft>
-              <a:buNone/>
-            </a:pPr>
-            <a:r>
-              <a:rPr lang="en-US" sz="3900" b="1">
-                <a:solidFill>
-                  <a:srgbClr val="F5F1E9"/>
-                </a:solidFill>
-                <a:latin typeface="Arial"/>
-                <a:ea typeface="Arial"/>
-                <a:cs typeface="Arial"/>
-              </a:rPr>
-              <a:t xml:space="preserve">The next surprise should cost less</a:t>
-            </a:r>
-            <a:endParaRPr lang="en-US" sz="3900"/>
-          </a:p>
-        </p:txBody>
-      </p:sp>
-      <p:sp>
-        <p:nvSpPr>
-          <p:cNvPr id="4" name="Text 4"/>
-          <p:cNvSpPr txBox="1"/>
-          <p:nvPr/>
-        </p:nvSpPr>
-        <p:spPr>
-          <a:xfrm>
-            <a:off x="685800" y="2771775"/>
-            <a:ext cx="904875" cy="476250"/>
-          </a:xfrm>
-          <a:prstGeom prst="rect">
-            <a:avLst/>
-          </a:prstGeom>
-          <a:noFill/>
-          <a:ln>
-            <a:noFill/>
-          </a:ln>
-        </p:spPr>
-        <p:txBody>
-          <a:bodyPr wrap="none" lIns="0" tIns="0" rIns="0" bIns="0" anchor="t">
-            <a:noAutofit/>
-          </a:bodyPr>
-          <a:lstStyle/>
-          <a:p>
-            <a:pPr marL="0" indent="0">
-              <a:lnSpc>
-                <a:spcPts val="2438"/>
-              </a:lnSpc>
-              <a:spcAft>
-                <a:spcPts val="0"/>
-              </a:spcAft>
-              <a:buNone/>
-            </a:pPr>
-            <a:r>
-              <a:rPr lang="en-US" sz="1875" b="0">
-                <a:solidFill>
-                  <a:srgbClr val="A4D2C4"/>
-                </a:solidFill>
-                <a:latin typeface="Arial"/>
-                <a:ea typeface="Arial"/>
-                <a:cs typeface="Arial"/>
-              </a:rPr>
-              <a:t xml:space="preserve">01</a:t>
-            </a:r>
-            <a:endParaRPr lang="en-US" sz="1875"/>
-          </a:p>
-        </p:txBody>
-      </p:sp>
-      <p:sp>
-        <p:nvSpPr>
-          <p:cNvPr id="5" name="Text 5"/>
-          <p:cNvSpPr txBox="1"/>
-          <p:nvPr/>
-        </p:nvSpPr>
-        <p:spPr>
-          <a:xfrm>
-            <a:off x="2000250" y="2771775"/>
             <a:ext cx="11029950" cy="539115"/>
           </a:xfrm>
           <a:prstGeom prst="rect">
@@ -7406,7 +5866,7 @@
                 <a:ea typeface="Arial"/>
                 <a:cs typeface="Arial"/>
               </a:rPr>
-              <a:t xml:space="preserve">8</a:t>
+              <a:t xml:space="preserve">7</a:t>
             </a:r>
             <a:endParaRPr lang="en-US" sz="975"/>
           </a:p>

</xml_diff>